<commit_message>
Simplify comments across codebase
</commit_message>
<xml_diff>
--- a/presentation.pptx
+++ b/presentation.pptx
@@ -229,7 +229,7 @@
           <a:p>
             <a:fld id="{48B45424-6BAC-416C-8F6C-5F9DE854A36B}" type="datetimeFigureOut">
               <a:rPr lang="en-US" smtClean="0"/>
-              <a:t>6/20/2026</a:t>
+              <a:t>6/22/2026</a:t>
             </a:fld>
             <a:endParaRPr lang="en-US"/>
           </a:p>
@@ -407,7 +407,7 @@
           <a:p>
             <a:fld id="{6B733702-C25A-40B9-9167-54BAA79B29B0}" type="datetimeFigureOut">
               <a:rPr lang="en-US" smtClean="0"/>
-              <a:t>6/20/2026</a:t>
+              <a:t>6/22/2026</a:t>
             </a:fld>
             <a:endParaRPr lang="en-US"/>
           </a:p>
@@ -793,7 +793,7 @@
             <a:fld id="{F70EAA40-3A53-4A3D-924A-D38F1059C7D5}" type="datetime1">
               <a:rPr lang="en-US" smtClean="0"/>
               <a:pPr/>
-              <a:t>6/20/2026</a:t>
+              <a:t>6/22/2026</a:t>
             </a:fld>
             <a:endParaRPr lang="en-US"/>
           </a:p>
@@ -1376,7 +1376,7 @@
             <a:fld id="{F70EAA40-3A53-4A3D-924A-D38F1059C7D5}" type="datetime1">
               <a:rPr lang="en-US" smtClean="0"/>
               <a:pPr/>
-              <a:t>6/20/2026</a:t>
+              <a:t>6/22/2026</a:t>
             </a:fld>
             <a:endParaRPr lang="en-US"/>
           </a:p>
@@ -1562,7 +1562,7 @@
             <a:fld id="{F70EAA40-3A53-4A3D-924A-D38F1059C7D5}" type="datetime1">
               <a:rPr lang="en-US" smtClean="0"/>
               <a:pPr/>
-              <a:t>6/20/2026</a:t>
+              <a:t>6/22/2026</a:t>
             </a:fld>
             <a:endParaRPr lang="en-US"/>
           </a:p>
@@ -1898,7 +1898,7 @@
             <a:fld id="{F70EAA40-3A53-4A3D-924A-D38F1059C7D5}" type="datetime1">
               <a:rPr lang="en-US" smtClean="0"/>
               <a:pPr/>
-              <a:t>6/20/2026</a:t>
+              <a:t>6/22/2026</a:t>
             </a:fld>
             <a:endParaRPr lang="en-US"/>
           </a:p>
@@ -2219,7 +2219,7 @@
             <a:fld id="{F70EAA40-3A53-4A3D-924A-D38F1059C7D5}" type="datetime1">
               <a:rPr lang="en-US" smtClean="0"/>
               <a:pPr/>
-              <a:t>6/20/2026</a:t>
+              <a:t>6/22/2026</a:t>
             </a:fld>
             <a:endParaRPr lang="en-US"/>
           </a:p>
@@ -2553,7 +2553,7 @@
             <a:fld id="{F70EAA40-3A53-4A3D-924A-D38F1059C7D5}" type="datetime1">
               <a:rPr lang="en-US" smtClean="0"/>
               <a:pPr/>
-              <a:t>6/20/2026</a:t>
+              <a:t>6/22/2026</a:t>
             </a:fld>
             <a:endParaRPr lang="en-US"/>
           </a:p>
@@ -2988,7 +2988,7 @@
             <a:fld id="{F70EAA40-3A53-4A3D-924A-D38F1059C7D5}" type="datetime1">
               <a:rPr lang="en-US" smtClean="0"/>
               <a:pPr/>
-              <a:t>6/20/2026</a:t>
+              <a:t>6/22/2026</a:t>
             </a:fld>
             <a:endParaRPr lang="en-US"/>
           </a:p>
@@ -3322,7 +3322,7 @@
             <a:fld id="{F70EAA40-3A53-4A3D-924A-D38F1059C7D5}" type="datetime1">
               <a:rPr lang="en-US" smtClean="0"/>
               <a:pPr/>
-              <a:t>6/20/2026</a:t>
+              <a:t>6/22/2026</a:t>
             </a:fld>
             <a:endParaRPr lang="en-US"/>
           </a:p>
@@ -3907,7 +3907,7 @@
             <a:fld id="{F70EAA40-3A53-4A3D-924A-D38F1059C7D5}" type="datetime1">
               <a:rPr lang="en-US" smtClean="0"/>
               <a:pPr/>
-              <a:t>6/20/2026</a:t>
+              <a:t>6/22/2026</a:t>
             </a:fld>
             <a:endParaRPr lang="en-US"/>
           </a:p>
@@ -4344,7 +4344,7 @@
             <a:fld id="{F70EAA40-3A53-4A3D-924A-D38F1059C7D5}" type="datetime1">
               <a:rPr lang="en-US" smtClean="0"/>
               <a:pPr/>
-              <a:t>6/20/2026</a:t>
+              <a:t>6/22/2026</a:t>
             </a:fld>
             <a:endParaRPr lang="en-US"/>
           </a:p>

</xml_diff>